<commit_message>
Presentation : precise n=20, association ecologique et date d'extraction
Suite a relecture avant envoi : la slide H1-bis n'affichait pas explicitement la
taille d'echantillon ni le rappel qu'il s'agit d'une association ecologique (deja
present dans le notebook, mais absent du support de restitution). Ajoute "n = 20
arrondissements" a cote du Spearman, et une ligne dediee "Association ecologique
(niveau arrondissement) -- ne permet pas de conclure au niveau d'une terrasse
individuelle". Ajoute aussi la date d'extraction des donnees (22 aout 2026) sur la
slide des sources de donnees.

Co-Authored-By: Claude Sonnet 5 <noreply@anthropic.com>
</commit_message>
<xml_diff>
--- a/presentation/presentation.pptx
+++ b/presentation/presentation.pptx
@@ -5218,6 +5218,40 @@
           </a:p>
         </p:txBody>
       </p:sp>
+      <p:sp>
+        <p:nvSpPr>
+          <p:cNvPr id="24" name="TextBox 23"/>
+          <p:cNvSpPr txBox="1"/>
+          <p:nvPr/>
+        </p:nvSpPr>
+        <p:spPr>
+          <a:xfrm>
+            <a:off x="640080" y="6263640"/>
+            <a:ext cx="10881360" cy="365760"/>
+          </a:xfrm>
+          <a:prstGeom prst="rect">
+            <a:avLst/>
+          </a:prstGeom>
+          <a:noFill/>
+        </p:spPr>
+        <p:txBody>
+          <a:bodyPr wrap="none">
+            <a:spAutoFit/>
+          </a:bodyPr>
+          <a:lstStyle/>
+          <a:p>
+            <a:r>
+              <a:rPr sz="1200" i="1">
+                <a:solidFill>
+                  <a:srgbClr val="4B5563"/>
+                </a:solidFill>
+                <a:latin typeface="Calibri"/>
+              </a:rPr>
+              <a:t>Donnees extraites le 22 aout 2026 depuis l'API Open Data Paris.</a:t>
+            </a:r>
+          </a:p>
+        </p:txBody>
+      </p:sp>
     </p:spTree>
   </p:cSld>
   <p:clrMapOvr>
@@ -6633,7 +6667,7 @@
                 </a:solidFill>
                 <a:latin typeface="Calibri"/>
               </a:rPr>
-              <a:t>Spearman = 0,544 (p = 0,013)</a:t>
+              <a:t>Spearman = 0,544 (p = 0,013 ; n = 20 arrondissements)</a:t>
             </a:r>
           </a:p>
         </p:txBody>
@@ -6662,7 +6696,7 @@
           <a:p>
             <a:pPr algn="l"/>
             <a:r>
-              <a:rPr sz="1400" b="0" i="0">
+              <a:rPr sz="1400">
                 <a:solidFill>
                   <a:srgbClr val="4B5563"/>
                 </a:solidFill>
@@ -6672,9 +6706,8 @@
             </a:r>
           </a:p>
           <a:p>
-            <a:pPr algn="l"/>
-            <a:r>
-              <a:rPr sz="1400" b="0" i="0">
+            <a:r>
+              <a:rPr sz="1400">
                 <a:solidFill>
                   <a:srgbClr val="4B5563"/>
                 </a:solidFill>
@@ -6684,9 +6717,8 @@
             </a:r>
           </a:p>
           <a:p>
-            <a:pPr algn="l"/>
-            <a:r>
-              <a:rPr sz="1400" b="0" i="0">
+            <a:r>
+              <a:rPr sz="1400">
                 <a:solidFill>
                   <a:srgbClr val="4B5563"/>
                 </a:solidFill>
@@ -6696,9 +6728,8 @@
             </a:r>
           </a:p>
           <a:p>
-            <a:pPr algn="l"/>
-            <a:r>
-              <a:rPr sz="1400" b="0" i="0">
+            <a:r>
+              <a:rPr sz="1400">
                 <a:solidFill>
                   <a:srgbClr val="4B5563"/>
                 </a:solidFill>
@@ -6708,15 +6739,47 @@
             </a:r>
           </a:p>
           <a:p>
-            <a:pPr algn="l"/>
-            <a:r>
-              <a:rPr sz="1400" b="0" i="0">
+            <a:r>
+              <a:rPr sz="1400">
                 <a:solidFill>
                   <a:srgbClr val="4B5563"/>
                 </a:solidFill>
                 <a:latin typeface="Calibri"/>
               </a:rPr>
               <a:t>selon le modele.</a:t>
+            </a:r>
+          </a:p>
+          <a:p>
+            <a:r>
+              <a:rPr sz="1400">
+                <a:solidFill>
+                  <a:srgbClr val="4B5563"/>
+                </a:solidFill>
+                <a:latin typeface="Calibri"/>
+              </a:rPr>
+              <a:t/>
+            </a:r>
+          </a:p>
+          <a:p>
+            <a:r>
+              <a:rPr sz="1400" b="1">
+                <a:solidFill>
+                  <a:srgbClr val="1F3A5F"/>
+                </a:solidFill>
+                <a:latin typeface="Calibri"/>
+              </a:rPr>
+              <a:t>Association ecologique (niveau arrondissement) -- ne</a:t>
+            </a:r>
+          </a:p>
+          <a:p>
+            <a:r>
+              <a:rPr sz="1400">
+                <a:solidFill>
+                  <a:srgbClr val="4B5563"/>
+                </a:solidFill>
+                <a:latin typeface="Calibri"/>
+              </a:rPr>
+              <a:t>permet pas de conclure au niveau d'une terrasse individuelle.</a:t>
             </a:r>
           </a:p>
         </p:txBody>

</xml_diff>